<commit_message>
Add SMC/LMC engagement data, regenerate reports, update prompts
- Add LMC/SMC monthly engagement CSVs + consolidated xlsx source
- Regenerate AI readiness scores, retrievability scores, and per-article HTML reports (538 new + refreshed)
- Consolidate prompt dimensions: remove cross-section-integrity, query-answer-alignment, redundancy-efficiency, semantic-density; refresh the remaining six
- Minor pipeline updates (generate_reports.py, run_ai_readiness.py, analyze_content.py)
- Refresh how-it-works deck + generator script
- Ignore .claude/ and data/logs/ (local artifacts); drop stale .env.example

Co-Authored-By: Claude Opus 4.7 (1M context) <noreply@anthropic.com>
</commit_message>
<xml_diff>
--- a/docs/content-dashboard-how-it-works.pptx
+++ b/docs/content-dashboard-how-it-works.pptx
@@ -5,18 +5,18 @@
     <p:sldMasterId id="2147483648" r:id="rId1"/>
   </p:sldMasterIdLst>
   <p:sldIdLst>
-    <p:sldId id="256" r:id="rId7"/>
-    <p:sldId id="257" r:id="rId8"/>
-    <p:sldId id="258" r:id="rId9"/>
-    <p:sldId id="259" r:id="rId10"/>
-    <p:sldId id="260" r:id="rId11"/>
-    <p:sldId id="261" r:id="rId12"/>
-    <p:sldId id="262" r:id="rId13"/>
-    <p:sldId id="263" r:id="rId14"/>
-    <p:sldId id="264" r:id="rId15"/>
-    <p:sldId id="265" r:id="rId16"/>
+    <p:sldId id="256" r:id="rId2"/>
+    <p:sldId id="257" r:id="rId3"/>
+    <p:sldId id="258" r:id="rId4"/>
+    <p:sldId id="259" r:id="rId5"/>
+    <p:sldId id="260" r:id="rId6"/>
+    <p:sldId id="261" r:id="rId7"/>
+    <p:sldId id="262" r:id="rId8"/>
+    <p:sldId id="263" r:id="rId9"/>
+    <p:sldId id="264" r:id="rId10"/>
+    <p:sldId id="265" r:id="rId11"/>
   </p:sldIdLst>
-  <p:sldSz cx="12191695" cy="6858000" type="screen4x3"/>
+  <p:sldSz cx="12192000" cy="6858000"/>
   <p:notesSz cx="6858000" cy="9144000"/>
   <p:defaultTextStyle>
     <a:defPPr>
@@ -113,6 +113,22 @@
       </a:defRPr>
     </a:lvl9pPr>
   </p:defaultTextStyle>
+  <p:extLst>
+    <p:ext uri="{EFAFB233-063F-42B5-8137-9DF3F51BA10A}">
+      <p15:sldGuideLst xmlns:p15="http://schemas.microsoft.com/office/powerpoint/2012/main">
+        <p15:guide id="1" orient="horz" pos="2160">
+          <p15:clr>
+            <a:srgbClr val="A4A3A4"/>
+          </p15:clr>
+        </p15:guide>
+        <p15:guide id="2" pos="2880">
+          <p15:clr>
+            <a:srgbClr val="A4A3A4"/>
+          </p15:clr>
+        </p15:guide>
+      </p15:sldGuideLst>
+    </p:ext>
+  </p:extLst>
 </p:presentation>
 </file>
 
@@ -154,10 +170,9 @@
           <a:lstStyle/>
           <a:p>
             <a:r>
-              <a:rPr lang="en-US" smtClean="0"/>
+              <a:rPr lang="en-US"/>
               <a:t>Click to edit Master title style</a:t>
             </a:r>
-            <a:endParaRPr lang="en-US"/>
           </a:p>
         </p:txBody>
       </p:sp>
@@ -273,10 +288,9 @@
           </a:lstStyle>
           <a:p>
             <a:r>
-              <a:rPr lang="en-US" smtClean="0"/>
+              <a:rPr lang="en-US"/>
               <a:t>Click to edit Master subtitle style</a:t>
             </a:r>
-            <a:endParaRPr lang="en-US"/>
           </a:p>
         </p:txBody>
       </p:sp>
@@ -297,7 +311,7 @@
           <a:p>
             <a:fld id="{5BCAD085-E8A6-8845-BD4E-CB4CCA059FC4}" type="datetimeFigureOut">
               <a:rPr lang="en-US" smtClean="0"/>
-              <a:t>1/27/13</a:t>
+              <a:t>3/19/2026</a:t>
             </a:fld>
             <a:endParaRPr lang="en-US"/>
           </a:p>
@@ -391,10 +405,9 @@
           <a:lstStyle/>
           <a:p>
             <a:r>
-              <a:rPr lang="en-US" smtClean="0"/>
+              <a:rPr lang="en-US"/>
               <a:t>Click to edit Master title style</a:t>
             </a:r>
-            <a:endParaRPr lang="en-US"/>
           </a:p>
         </p:txBody>
       </p:sp>
@@ -415,38 +428,37 @@
           <a:p>
             <a:pPr lvl="0"/>
             <a:r>
-              <a:rPr lang="en-US" smtClean="0"/>
+              <a:rPr lang="en-US"/>
               <a:t>Click to edit Master text styles</a:t>
             </a:r>
           </a:p>
           <a:p>
             <a:pPr lvl="1"/>
             <a:r>
-              <a:rPr lang="en-US" smtClean="0"/>
+              <a:rPr lang="en-US"/>
               <a:t>Second level</a:t>
             </a:r>
           </a:p>
           <a:p>
             <a:pPr lvl="2"/>
             <a:r>
-              <a:rPr lang="en-US" smtClean="0"/>
+              <a:rPr lang="en-US"/>
               <a:t>Third level</a:t>
             </a:r>
           </a:p>
           <a:p>
             <a:pPr lvl="3"/>
             <a:r>
-              <a:rPr lang="en-US" smtClean="0"/>
+              <a:rPr lang="en-US"/>
               <a:t>Fourth level</a:t>
             </a:r>
           </a:p>
           <a:p>
             <a:pPr lvl="4"/>
             <a:r>
-              <a:rPr lang="en-US" smtClean="0"/>
+              <a:rPr lang="en-US"/>
               <a:t>Fifth level</a:t>
             </a:r>
-            <a:endParaRPr lang="en-US"/>
           </a:p>
         </p:txBody>
       </p:sp>
@@ -467,7 +479,7 @@
           <a:p>
             <a:fld id="{5BCAD085-E8A6-8845-BD4E-CB4CCA059FC4}" type="datetimeFigureOut">
               <a:rPr lang="en-US" smtClean="0"/>
-              <a:t>1/27/13</a:t>
+              <a:t>3/19/2026</a:t>
             </a:fld>
             <a:endParaRPr lang="en-US"/>
           </a:p>
@@ -566,10 +578,9 @@
           <a:lstStyle/>
           <a:p>
             <a:r>
-              <a:rPr lang="en-US" smtClean="0"/>
+              <a:rPr lang="en-US"/>
               <a:t>Click to edit Master title style</a:t>
             </a:r>
-            <a:endParaRPr lang="en-US"/>
           </a:p>
         </p:txBody>
       </p:sp>
@@ -595,38 +606,37 @@
           <a:p>
             <a:pPr lvl="0"/>
             <a:r>
-              <a:rPr lang="en-US" smtClean="0"/>
+              <a:rPr lang="en-US"/>
               <a:t>Click to edit Master text styles</a:t>
             </a:r>
           </a:p>
           <a:p>
             <a:pPr lvl="1"/>
             <a:r>
-              <a:rPr lang="en-US" smtClean="0"/>
+              <a:rPr lang="en-US"/>
               <a:t>Second level</a:t>
             </a:r>
           </a:p>
           <a:p>
             <a:pPr lvl="2"/>
             <a:r>
-              <a:rPr lang="en-US" smtClean="0"/>
+              <a:rPr lang="en-US"/>
               <a:t>Third level</a:t>
             </a:r>
           </a:p>
           <a:p>
             <a:pPr lvl="3"/>
             <a:r>
-              <a:rPr lang="en-US" smtClean="0"/>
+              <a:rPr lang="en-US"/>
               <a:t>Fourth level</a:t>
             </a:r>
           </a:p>
           <a:p>
             <a:pPr lvl="4"/>
             <a:r>
-              <a:rPr lang="en-US" smtClean="0"/>
+              <a:rPr lang="en-US"/>
               <a:t>Fifth level</a:t>
             </a:r>
-            <a:endParaRPr lang="en-US"/>
           </a:p>
         </p:txBody>
       </p:sp>
@@ -647,7 +657,7 @@
           <a:p>
             <a:fld id="{5BCAD085-E8A6-8845-BD4E-CB4CCA059FC4}" type="datetimeFigureOut">
               <a:rPr lang="en-US" smtClean="0"/>
-              <a:t>1/27/13</a:t>
+              <a:t>3/19/2026</a:t>
             </a:fld>
             <a:endParaRPr lang="en-US"/>
           </a:p>
@@ -741,10 +751,9 @@
           <a:lstStyle/>
           <a:p>
             <a:r>
-              <a:rPr lang="en-US" smtClean="0"/>
+              <a:rPr lang="en-US"/>
               <a:t>Click to edit Master title style</a:t>
             </a:r>
-            <a:endParaRPr lang="en-US"/>
           </a:p>
         </p:txBody>
       </p:sp>
@@ -765,38 +774,37 @@
           <a:p>
             <a:pPr lvl="0"/>
             <a:r>
-              <a:rPr lang="en-US" smtClean="0"/>
+              <a:rPr lang="en-US"/>
               <a:t>Click to edit Master text styles</a:t>
             </a:r>
           </a:p>
           <a:p>
             <a:pPr lvl="1"/>
             <a:r>
-              <a:rPr lang="en-US" smtClean="0"/>
+              <a:rPr lang="en-US"/>
               <a:t>Second level</a:t>
             </a:r>
           </a:p>
           <a:p>
             <a:pPr lvl="2"/>
             <a:r>
-              <a:rPr lang="en-US" smtClean="0"/>
+              <a:rPr lang="en-US"/>
               <a:t>Third level</a:t>
             </a:r>
           </a:p>
           <a:p>
             <a:pPr lvl="3"/>
             <a:r>
-              <a:rPr lang="en-US" smtClean="0"/>
+              <a:rPr lang="en-US"/>
               <a:t>Fourth level</a:t>
             </a:r>
           </a:p>
           <a:p>
             <a:pPr lvl="4"/>
             <a:r>
-              <a:rPr lang="en-US" smtClean="0"/>
+              <a:rPr lang="en-US"/>
               <a:t>Fifth level</a:t>
             </a:r>
-            <a:endParaRPr lang="en-US"/>
           </a:p>
         </p:txBody>
       </p:sp>
@@ -817,7 +825,7 @@
           <a:p>
             <a:fld id="{5BCAD085-E8A6-8845-BD4E-CB4CCA059FC4}" type="datetimeFigureOut">
               <a:rPr lang="en-US" smtClean="0"/>
-              <a:t>1/27/13</a:t>
+              <a:t>3/19/2026</a:t>
             </a:fld>
             <a:endParaRPr lang="en-US"/>
           </a:p>
@@ -920,10 +928,9 @@
           </a:lstStyle>
           <a:p>
             <a:r>
-              <a:rPr lang="en-US" smtClean="0"/>
+              <a:rPr lang="en-US"/>
               <a:t>Click to edit Master title style</a:t>
             </a:r>
-            <a:endParaRPr lang="en-US"/>
           </a:p>
         </p:txBody>
       </p:sp>
@@ -1040,7 +1047,7 @@
           <a:p>
             <a:pPr lvl="0"/>
             <a:r>
-              <a:rPr lang="en-US" smtClean="0"/>
+              <a:rPr lang="en-US"/>
               <a:t>Click to edit Master text styles</a:t>
             </a:r>
           </a:p>
@@ -1063,7 +1070,7 @@
           <a:p>
             <a:fld id="{5BCAD085-E8A6-8845-BD4E-CB4CCA059FC4}" type="datetimeFigureOut">
               <a:rPr lang="en-US" smtClean="0"/>
-              <a:t>1/27/13</a:t>
+              <a:t>3/19/2026</a:t>
             </a:fld>
             <a:endParaRPr lang="en-US"/>
           </a:p>
@@ -1157,10 +1164,9 @@
           <a:lstStyle/>
           <a:p>
             <a:r>
-              <a:rPr lang="en-US" smtClean="0"/>
+              <a:rPr lang="en-US"/>
               <a:t>Click to edit Master title style</a:t>
             </a:r>
-            <a:endParaRPr lang="en-US"/>
           </a:p>
         </p:txBody>
       </p:sp>
@@ -1214,38 +1220,37 @@
           <a:p>
             <a:pPr lvl="0"/>
             <a:r>
-              <a:rPr lang="en-US" smtClean="0"/>
+              <a:rPr lang="en-US"/>
               <a:t>Click to edit Master text styles</a:t>
             </a:r>
           </a:p>
           <a:p>
             <a:pPr lvl="1"/>
             <a:r>
-              <a:rPr lang="en-US" smtClean="0"/>
+              <a:rPr lang="en-US"/>
               <a:t>Second level</a:t>
             </a:r>
           </a:p>
           <a:p>
             <a:pPr lvl="2"/>
             <a:r>
-              <a:rPr lang="en-US" smtClean="0"/>
+              <a:rPr lang="en-US"/>
               <a:t>Third level</a:t>
             </a:r>
           </a:p>
           <a:p>
             <a:pPr lvl="3"/>
             <a:r>
-              <a:rPr lang="en-US" smtClean="0"/>
+              <a:rPr lang="en-US"/>
               <a:t>Fourth level</a:t>
             </a:r>
           </a:p>
           <a:p>
             <a:pPr lvl="4"/>
             <a:r>
-              <a:rPr lang="en-US" smtClean="0"/>
+              <a:rPr lang="en-US"/>
               <a:t>Fifth level</a:t>
             </a:r>
-            <a:endParaRPr lang="en-US"/>
           </a:p>
         </p:txBody>
       </p:sp>
@@ -1299,38 +1304,37 @@
           <a:p>
             <a:pPr lvl="0"/>
             <a:r>
-              <a:rPr lang="en-US" smtClean="0"/>
+              <a:rPr lang="en-US"/>
               <a:t>Click to edit Master text styles</a:t>
             </a:r>
           </a:p>
           <a:p>
             <a:pPr lvl="1"/>
             <a:r>
-              <a:rPr lang="en-US" smtClean="0"/>
+              <a:rPr lang="en-US"/>
               <a:t>Second level</a:t>
             </a:r>
           </a:p>
           <a:p>
             <a:pPr lvl="2"/>
             <a:r>
-              <a:rPr lang="en-US" smtClean="0"/>
+              <a:rPr lang="en-US"/>
               <a:t>Third level</a:t>
             </a:r>
           </a:p>
           <a:p>
             <a:pPr lvl="3"/>
             <a:r>
-              <a:rPr lang="en-US" smtClean="0"/>
+              <a:rPr lang="en-US"/>
               <a:t>Fourth level</a:t>
             </a:r>
           </a:p>
           <a:p>
             <a:pPr lvl="4"/>
             <a:r>
-              <a:rPr lang="en-US" smtClean="0"/>
+              <a:rPr lang="en-US"/>
               <a:t>Fifth level</a:t>
             </a:r>
-            <a:endParaRPr lang="en-US"/>
           </a:p>
         </p:txBody>
       </p:sp>
@@ -1351,7 +1355,7 @@
           <a:p>
             <a:fld id="{5BCAD085-E8A6-8845-BD4E-CB4CCA059FC4}" type="datetimeFigureOut">
               <a:rPr lang="en-US" smtClean="0"/>
-              <a:t>1/27/13</a:t>
+              <a:t>3/19/2026</a:t>
             </a:fld>
             <a:endParaRPr lang="en-US"/>
           </a:p>
@@ -1449,10 +1453,9 @@
           </a:lstStyle>
           <a:p>
             <a:r>
-              <a:rPr lang="en-US" smtClean="0"/>
+              <a:rPr lang="en-US"/>
               <a:t>Click to edit Master title style</a:t>
             </a:r>
-            <a:endParaRPr lang="en-US"/>
           </a:p>
         </p:txBody>
       </p:sp>
@@ -1515,7 +1518,7 @@
           <a:p>
             <a:pPr lvl="0"/>
             <a:r>
-              <a:rPr lang="en-US" smtClean="0"/>
+              <a:rPr lang="en-US"/>
               <a:t>Click to edit Master text styles</a:t>
             </a:r>
           </a:p>
@@ -1571,38 +1574,37 @@
           <a:p>
             <a:pPr lvl="0"/>
             <a:r>
-              <a:rPr lang="en-US" smtClean="0"/>
+              <a:rPr lang="en-US"/>
               <a:t>Click to edit Master text styles</a:t>
             </a:r>
           </a:p>
           <a:p>
             <a:pPr lvl="1"/>
             <a:r>
-              <a:rPr lang="en-US" smtClean="0"/>
+              <a:rPr lang="en-US"/>
               <a:t>Second level</a:t>
             </a:r>
           </a:p>
           <a:p>
             <a:pPr lvl="2"/>
             <a:r>
-              <a:rPr lang="en-US" smtClean="0"/>
+              <a:rPr lang="en-US"/>
               <a:t>Third level</a:t>
             </a:r>
           </a:p>
           <a:p>
             <a:pPr lvl="3"/>
             <a:r>
-              <a:rPr lang="en-US" smtClean="0"/>
+              <a:rPr lang="en-US"/>
               <a:t>Fourth level</a:t>
             </a:r>
           </a:p>
           <a:p>
             <a:pPr lvl="4"/>
             <a:r>
-              <a:rPr lang="en-US" smtClean="0"/>
+              <a:rPr lang="en-US"/>
               <a:t>Fifth level</a:t>
             </a:r>
-            <a:endParaRPr lang="en-US"/>
           </a:p>
         </p:txBody>
       </p:sp>
@@ -1665,7 +1667,7 @@
           <a:p>
             <a:pPr lvl="0"/>
             <a:r>
-              <a:rPr lang="en-US" smtClean="0"/>
+              <a:rPr lang="en-US"/>
               <a:t>Click to edit Master text styles</a:t>
             </a:r>
           </a:p>
@@ -1721,38 +1723,37 @@
           <a:p>
             <a:pPr lvl="0"/>
             <a:r>
-              <a:rPr lang="en-US" smtClean="0"/>
+              <a:rPr lang="en-US"/>
               <a:t>Click to edit Master text styles</a:t>
             </a:r>
           </a:p>
           <a:p>
             <a:pPr lvl="1"/>
             <a:r>
-              <a:rPr lang="en-US" smtClean="0"/>
+              <a:rPr lang="en-US"/>
               <a:t>Second level</a:t>
             </a:r>
           </a:p>
           <a:p>
             <a:pPr lvl="2"/>
             <a:r>
-              <a:rPr lang="en-US" smtClean="0"/>
+              <a:rPr lang="en-US"/>
               <a:t>Third level</a:t>
             </a:r>
           </a:p>
           <a:p>
             <a:pPr lvl="3"/>
             <a:r>
-              <a:rPr lang="en-US" smtClean="0"/>
+              <a:rPr lang="en-US"/>
               <a:t>Fourth level</a:t>
             </a:r>
           </a:p>
           <a:p>
             <a:pPr lvl="4"/>
             <a:r>
-              <a:rPr lang="en-US" smtClean="0"/>
+              <a:rPr lang="en-US"/>
               <a:t>Fifth level</a:t>
             </a:r>
-            <a:endParaRPr lang="en-US"/>
           </a:p>
         </p:txBody>
       </p:sp>
@@ -1773,7 +1774,7 @@
           <a:p>
             <a:fld id="{5BCAD085-E8A6-8845-BD4E-CB4CCA059FC4}" type="datetimeFigureOut">
               <a:rPr lang="en-US" smtClean="0"/>
-              <a:t>1/27/13</a:t>
+              <a:t>3/19/2026</a:t>
             </a:fld>
             <a:endParaRPr lang="en-US"/>
           </a:p>
@@ -1867,10 +1868,9 @@
           <a:lstStyle/>
           <a:p>
             <a:r>
-              <a:rPr lang="en-US" smtClean="0"/>
+              <a:rPr lang="en-US"/>
               <a:t>Click to edit Master title style</a:t>
             </a:r>
-            <a:endParaRPr lang="en-US"/>
           </a:p>
         </p:txBody>
       </p:sp>
@@ -1891,7 +1891,7 @@
           <a:p>
             <a:fld id="{5BCAD085-E8A6-8845-BD4E-CB4CCA059FC4}" type="datetimeFigureOut">
               <a:rPr lang="en-US" smtClean="0"/>
-              <a:t>1/27/13</a:t>
+              <a:t>3/19/2026</a:t>
             </a:fld>
             <a:endParaRPr lang="en-US"/>
           </a:p>
@@ -1986,7 +1986,7 @@
           <a:p>
             <a:fld id="{5BCAD085-E8A6-8845-BD4E-CB4CCA059FC4}" type="datetimeFigureOut">
               <a:rPr lang="en-US" smtClean="0"/>
-              <a:t>1/27/13</a:t>
+              <a:t>3/19/2026</a:t>
             </a:fld>
             <a:endParaRPr lang="en-US"/>
           </a:p>
@@ -2089,10 +2089,9 @@
           </a:lstStyle>
           <a:p>
             <a:r>
-              <a:rPr lang="en-US" smtClean="0"/>
+              <a:rPr lang="en-US"/>
               <a:t>Click to edit Master title style</a:t>
             </a:r>
-            <a:endParaRPr lang="en-US"/>
           </a:p>
         </p:txBody>
       </p:sp>
@@ -2146,38 +2145,37 @@
           <a:p>
             <a:pPr lvl="0"/>
             <a:r>
-              <a:rPr lang="en-US" smtClean="0"/>
+              <a:rPr lang="en-US"/>
               <a:t>Click to edit Master text styles</a:t>
             </a:r>
           </a:p>
           <a:p>
             <a:pPr lvl="1"/>
             <a:r>
-              <a:rPr lang="en-US" smtClean="0"/>
+              <a:rPr lang="en-US"/>
               <a:t>Second level</a:t>
             </a:r>
           </a:p>
           <a:p>
             <a:pPr lvl="2"/>
             <a:r>
-              <a:rPr lang="en-US" smtClean="0"/>
+              <a:rPr lang="en-US"/>
               <a:t>Third level</a:t>
             </a:r>
           </a:p>
           <a:p>
             <a:pPr lvl="3"/>
             <a:r>
-              <a:rPr lang="en-US" smtClean="0"/>
+              <a:rPr lang="en-US"/>
               <a:t>Fourth level</a:t>
             </a:r>
           </a:p>
           <a:p>
             <a:pPr lvl="4"/>
             <a:r>
-              <a:rPr lang="en-US" smtClean="0"/>
+              <a:rPr lang="en-US"/>
               <a:t>Fifth level</a:t>
             </a:r>
-            <a:endParaRPr lang="en-US"/>
           </a:p>
         </p:txBody>
       </p:sp>
@@ -2240,7 +2238,7 @@
           <a:p>
             <a:pPr lvl="0"/>
             <a:r>
-              <a:rPr lang="en-US" smtClean="0"/>
+              <a:rPr lang="en-US"/>
               <a:t>Click to edit Master text styles</a:t>
             </a:r>
           </a:p>
@@ -2263,7 +2261,7 @@
           <a:p>
             <a:fld id="{5BCAD085-E8A6-8845-BD4E-CB4CCA059FC4}" type="datetimeFigureOut">
               <a:rPr lang="en-US" smtClean="0"/>
-              <a:t>1/27/13</a:t>
+              <a:t>3/19/2026</a:t>
             </a:fld>
             <a:endParaRPr lang="en-US"/>
           </a:p>
@@ -2366,10 +2364,9 @@
           </a:lstStyle>
           <a:p>
             <a:r>
-              <a:rPr lang="en-US" smtClean="0"/>
+              <a:rPr lang="en-US"/>
               <a:t>Click to edit Master title style</a:t>
             </a:r>
-            <a:endParaRPr lang="en-US"/>
           </a:p>
         </p:txBody>
       </p:sp>
@@ -2493,7 +2490,7 @@
           <a:p>
             <a:pPr lvl="0"/>
             <a:r>
-              <a:rPr lang="en-US" smtClean="0"/>
+              <a:rPr lang="en-US"/>
               <a:t>Click to edit Master text styles</a:t>
             </a:r>
           </a:p>
@@ -2516,7 +2513,7 @@
           <a:p>
             <a:fld id="{5BCAD085-E8A6-8845-BD4E-CB4CCA059FC4}" type="datetimeFigureOut">
               <a:rPr lang="en-US" smtClean="0"/>
-              <a:t>1/27/13</a:t>
+              <a:t>3/19/2026</a:t>
             </a:fld>
             <a:endParaRPr lang="en-US"/>
           </a:p>
@@ -2625,10 +2622,9 @@
           <a:lstStyle/>
           <a:p>
             <a:r>
-              <a:rPr lang="en-US" smtClean="0"/>
+              <a:rPr lang="en-US"/>
               <a:t>Click to edit Master title style</a:t>
             </a:r>
-            <a:endParaRPr lang="en-US"/>
           </a:p>
         </p:txBody>
       </p:sp>
@@ -2659,38 +2655,37 @@
           <a:p>
             <a:pPr lvl="0"/>
             <a:r>
-              <a:rPr lang="en-US" smtClean="0"/>
+              <a:rPr lang="en-US"/>
               <a:t>Click to edit Master text styles</a:t>
             </a:r>
           </a:p>
           <a:p>
             <a:pPr lvl="1"/>
             <a:r>
-              <a:rPr lang="en-US" smtClean="0"/>
+              <a:rPr lang="en-US"/>
               <a:t>Second level</a:t>
             </a:r>
           </a:p>
           <a:p>
             <a:pPr lvl="2"/>
             <a:r>
-              <a:rPr lang="en-US" smtClean="0"/>
+              <a:rPr lang="en-US"/>
               <a:t>Third level</a:t>
             </a:r>
           </a:p>
           <a:p>
             <a:pPr lvl="3"/>
             <a:r>
-              <a:rPr lang="en-US" smtClean="0"/>
+              <a:rPr lang="en-US"/>
               <a:t>Fourth level</a:t>
             </a:r>
           </a:p>
           <a:p>
             <a:pPr lvl="4"/>
             <a:r>
-              <a:rPr lang="en-US" smtClean="0"/>
+              <a:rPr lang="en-US"/>
               <a:t>Fifth level</a:t>
             </a:r>
-            <a:endParaRPr lang="en-US"/>
           </a:p>
         </p:txBody>
       </p:sp>
@@ -2729,7 +2724,7 @@
           <a:p>
             <a:fld id="{5BCAD085-E8A6-8845-BD4E-CB4CCA059FC4}" type="datetimeFigureOut">
               <a:rPr lang="en-US" smtClean="0"/>
-              <a:t>1/27/13</a:t>
+              <a:t>3/19/2026</a:t>
             </a:fld>
             <a:endParaRPr lang="en-US"/>
           </a:p>
@@ -3088,7 +3083,7 @@
 </file>
 
 <file path=ppt/slides/slide1.xml><?xml version="1.0" encoding="utf-8"?>
-<p:sld xmlns:a="http://schemas.openxmlformats.org/drawingml/2006/main" xmlns:p="http://schemas.openxmlformats.org/presentationml/2006/main" xmlns:r="http://schemas.openxmlformats.org/officeDocument/2006/relationships">
+<p:sld xmlns:a="http://schemas.openxmlformats.org/drawingml/2006/main" xmlns:r="http://schemas.openxmlformats.org/officeDocument/2006/relationships" xmlns:p="http://schemas.openxmlformats.org/presentationml/2006/main">
   <p:cSld>
     <p:spTree>
       <p:nvGrpSpPr>
@@ -3096,7 +3091,14 @@
         <p:cNvGrpSpPr/>
         <p:nvPr/>
       </p:nvGrpSpPr>
-      <p:grpSpPr/>
+      <p:grpSpPr>
+        <a:xfrm>
+          <a:off x="0" y="0"/>
+          <a:ext cx="0" cy="0"/>
+          <a:chOff x="0" y="0"/>
+          <a:chExt cx="0" cy="0"/>
+        </a:xfrm>
+      </p:grpSpPr>
       <p:sp>
         <p:nvSpPr>
           <p:cNvPr id="2" name="Rectangle 1"/>
@@ -3137,6 +3139,7 @@
           <a:lstStyle/>
           <a:p>
             <a:pPr algn="ctr"/>
+            <a:endParaRPr/>
           </a:p>
         </p:txBody>
       </p:sp>
@@ -3180,6 +3183,7 @@
           <a:lstStyle/>
           <a:p>
             <a:pPr algn="ctr"/>
+            <a:endParaRPr/>
           </a:p>
         </p:txBody>
       </p:sp>
@@ -3277,7 +3281,7 @@
           <a:p>
             <a:pPr algn="l"/>
             <a:r>
-              <a:rPr sz="1600" b="0">
+              <a:rPr sz="1600" b="0" dirty="0">
                 <a:solidFill>
                   <a:srgbClr val="DEECF9"/>
                 </a:solidFill>
@@ -3297,7 +3301,7 @@
 </file>
 
 <file path=ppt/slides/slide10.xml><?xml version="1.0" encoding="utf-8"?>
-<p:sld xmlns:a="http://schemas.openxmlformats.org/drawingml/2006/main" xmlns:p="http://schemas.openxmlformats.org/presentationml/2006/main" xmlns:r="http://schemas.openxmlformats.org/officeDocument/2006/relationships">
+<p:sld xmlns:a="http://schemas.openxmlformats.org/drawingml/2006/main" xmlns:r="http://schemas.openxmlformats.org/officeDocument/2006/relationships" xmlns:p="http://schemas.openxmlformats.org/presentationml/2006/main">
   <p:cSld>
     <p:spTree>
       <p:nvGrpSpPr>
@@ -3305,7 +3309,14 @@
         <p:cNvGrpSpPr/>
         <p:nvPr/>
       </p:nvGrpSpPr>
-      <p:grpSpPr/>
+      <p:grpSpPr>
+        <a:xfrm>
+          <a:off x="0" y="0"/>
+          <a:ext cx="0" cy="0"/>
+          <a:chOff x="0" y="0"/>
+          <a:chExt cx="0" cy="0"/>
+        </a:xfrm>
+      </p:grpSpPr>
       <p:sp>
         <p:nvSpPr>
           <p:cNvPr id="2" name="Rectangle 1"/>
@@ -3346,6 +3357,7 @@
           <a:lstStyle/>
           <a:p>
             <a:pPr algn="ctr"/>
+            <a:endParaRPr/>
           </a:p>
         </p:txBody>
       </p:sp>
@@ -3389,6 +3401,7 @@
           <a:lstStyle/>
           <a:p>
             <a:pPr algn="ctr"/>
+            <a:endParaRPr/>
           </a:p>
         </p:txBody>
       </p:sp>
@@ -3502,6 +3515,7 @@
           <a:lstStyle/>
           <a:p>
             <a:pPr algn="ctr"/>
+            <a:endParaRPr/>
           </a:p>
         </p:txBody>
       </p:sp>
@@ -3695,7 +3709,7 @@
 </file>
 
 <file path=ppt/slides/slide2.xml><?xml version="1.0" encoding="utf-8"?>
-<p:sld xmlns:a="http://schemas.openxmlformats.org/drawingml/2006/main" xmlns:p="http://schemas.openxmlformats.org/presentationml/2006/main" xmlns:r="http://schemas.openxmlformats.org/officeDocument/2006/relationships">
+<p:sld xmlns:a="http://schemas.openxmlformats.org/drawingml/2006/main" xmlns:r="http://schemas.openxmlformats.org/officeDocument/2006/relationships" xmlns:p="http://schemas.openxmlformats.org/presentationml/2006/main">
   <p:cSld>
     <p:spTree>
       <p:nvGrpSpPr>
@@ -3703,7 +3717,14 @@
         <p:cNvGrpSpPr/>
         <p:nvPr/>
       </p:nvGrpSpPr>
-      <p:grpSpPr/>
+      <p:grpSpPr>
+        <a:xfrm>
+          <a:off x="0" y="0"/>
+          <a:ext cx="0" cy="0"/>
+          <a:chOff x="0" y="0"/>
+          <a:chExt cx="0" cy="0"/>
+        </a:xfrm>
+      </p:grpSpPr>
       <p:sp>
         <p:nvSpPr>
           <p:cNvPr id="2" name="Rectangle 1"/>
@@ -3744,6 +3765,7 @@
           <a:lstStyle/>
           <a:p>
             <a:pPr algn="ctr"/>
+            <a:endParaRPr/>
           </a:p>
         </p:txBody>
       </p:sp>
@@ -3787,6 +3809,7 @@
           <a:lstStyle/>
           <a:p>
             <a:pPr algn="ctr"/>
+            <a:endParaRPr/>
           </a:p>
         </p:txBody>
       </p:sp>
@@ -3900,6 +3923,7 @@
           <a:lstStyle/>
           <a:p>
             <a:pPr algn="ctr"/>
+            <a:endParaRPr/>
           </a:p>
         </p:txBody>
       </p:sp>
@@ -3980,6 +4004,7 @@
           <a:lstStyle/>
           <a:p>
             <a:pPr algn="ctr"/>
+            <a:endParaRPr/>
           </a:p>
         </p:txBody>
       </p:sp>
@@ -4182,6 +4207,7 @@
           <a:lstStyle/>
           <a:p>
             <a:pPr algn="ctr"/>
+            <a:endParaRPr/>
           </a:p>
         </p:txBody>
       </p:sp>
@@ -4421,7 +4447,7 @@
 </file>
 
 <file path=ppt/slides/slide3.xml><?xml version="1.0" encoding="utf-8"?>
-<p:sld xmlns:a="http://schemas.openxmlformats.org/drawingml/2006/main" xmlns:p="http://schemas.openxmlformats.org/presentationml/2006/main" xmlns:r="http://schemas.openxmlformats.org/officeDocument/2006/relationships">
+<p:sld xmlns:a="http://schemas.openxmlformats.org/drawingml/2006/main" xmlns:r="http://schemas.openxmlformats.org/officeDocument/2006/relationships" xmlns:p="http://schemas.openxmlformats.org/presentationml/2006/main">
   <p:cSld>
     <p:spTree>
       <p:nvGrpSpPr>
@@ -4429,7 +4455,14 @@
         <p:cNvGrpSpPr/>
         <p:nvPr/>
       </p:nvGrpSpPr>
-      <p:grpSpPr/>
+      <p:grpSpPr>
+        <a:xfrm>
+          <a:off x="0" y="0"/>
+          <a:ext cx="0" cy="0"/>
+          <a:chOff x="0" y="0"/>
+          <a:chExt cx="0" cy="0"/>
+        </a:xfrm>
+      </p:grpSpPr>
       <p:sp>
         <p:nvSpPr>
           <p:cNvPr id="2" name="Rectangle 1"/>
@@ -4470,6 +4503,7 @@
           <a:lstStyle/>
           <a:p>
             <a:pPr algn="ctr"/>
+            <a:endParaRPr/>
           </a:p>
         </p:txBody>
       </p:sp>
@@ -4513,6 +4547,7 @@
           <a:lstStyle/>
           <a:p>
             <a:pPr algn="ctr"/>
+            <a:endParaRPr/>
           </a:p>
         </p:txBody>
       </p:sp>
@@ -4626,6 +4661,7 @@
           <a:lstStyle/>
           <a:p>
             <a:pPr algn="ctr"/>
+            <a:endParaRPr/>
           </a:p>
         </p:txBody>
       </p:sp>
@@ -4704,6 +4740,7 @@
           <a:lstStyle/>
           <a:p>
             <a:pPr algn="ctr"/>
+            <a:endParaRPr/>
           </a:p>
         </p:txBody>
       </p:sp>
@@ -4854,6 +4891,7 @@
           <a:lstStyle/>
           <a:p>
             <a:pPr algn="ctr"/>
+            <a:endParaRPr/>
           </a:p>
         </p:txBody>
       </p:sp>
@@ -5004,6 +5042,7 @@
           <a:lstStyle/>
           <a:p>
             <a:pPr algn="ctr"/>
+            <a:endParaRPr/>
           </a:p>
         </p:txBody>
       </p:sp>
@@ -5154,6 +5193,7 @@
           <a:lstStyle/>
           <a:p>
             <a:pPr algn="ctr"/>
+            <a:endParaRPr/>
           </a:p>
         </p:txBody>
       </p:sp>
@@ -5304,6 +5344,7 @@
           <a:lstStyle/>
           <a:p>
             <a:pPr algn="ctr"/>
+            <a:endParaRPr/>
           </a:p>
         </p:txBody>
       </p:sp>
@@ -5454,6 +5495,7 @@
           <a:lstStyle/>
           <a:p>
             <a:pPr algn="ctr"/>
+            <a:endParaRPr/>
           </a:p>
         </p:txBody>
       </p:sp>
@@ -5537,7 +5579,7 @@
         </p:nvSpPr>
         <p:spPr>
           <a:xfrm>
-            <a:off x="2057400" y="3337560"/>
+            <a:off x="2057400" y="3782060"/>
             <a:ext cx="1828800" cy="548640"/>
           </a:xfrm>
           <a:prstGeom prst="rect">
@@ -5571,6 +5613,7 @@
           <a:lstStyle/>
           <a:p>
             <a:pPr algn="ctr"/>
+            <a:endParaRPr/>
           </a:p>
         </p:txBody>
       </p:sp>
@@ -5582,7 +5625,7 @@
         </p:nvSpPr>
         <p:spPr>
           <a:xfrm>
-            <a:off x="2057400" y="3364992"/>
+            <a:off x="2057400" y="3787140"/>
             <a:ext cx="1828800" cy="502920"/>
           </a:xfrm>
           <a:prstGeom prst="rect">
@@ -5619,7 +5662,7 @@
         </p:nvSpPr>
         <p:spPr>
           <a:xfrm>
-            <a:off x="4251960" y="3337560"/>
+            <a:off x="4244187" y="3764280"/>
             <a:ext cx="1828800" cy="548640"/>
           </a:xfrm>
           <a:prstGeom prst="rect">
@@ -5653,6 +5696,7 @@
           <a:lstStyle/>
           <a:p>
             <a:pPr algn="ctr"/>
+            <a:endParaRPr/>
           </a:p>
         </p:txBody>
       </p:sp>
@@ -5664,7 +5708,7 @@
         </p:nvSpPr>
         <p:spPr>
           <a:xfrm>
-            <a:off x="4251960" y="3364992"/>
+            <a:off x="4251960" y="3813048"/>
             <a:ext cx="1828800" cy="502920"/>
           </a:xfrm>
           <a:prstGeom prst="rect">
@@ -5680,7 +5724,7 @@
           <a:p>
             <a:pPr algn="ctr"/>
             <a:r>
-              <a:rPr sz="800" b="0">
+              <a:rPr sz="800" b="0" dirty="0">
                 <a:solidFill>
                   <a:srgbClr val="605E5C"/>
                 </a:solidFill>
@@ -5701,7 +5745,7 @@
         </p:nvSpPr>
         <p:spPr>
           <a:xfrm>
-            <a:off x="6446520" y="3337560"/>
+            <a:off x="6446520" y="3767328"/>
             <a:ext cx="1828800" cy="548640"/>
           </a:xfrm>
           <a:prstGeom prst="rect">
@@ -5735,6 +5779,7 @@
           <a:lstStyle/>
           <a:p>
             <a:pPr algn="ctr"/>
+            <a:endParaRPr/>
           </a:p>
         </p:txBody>
       </p:sp>
@@ -5746,7 +5791,7 @@
         </p:nvSpPr>
         <p:spPr>
           <a:xfrm>
-            <a:off x="6446520" y="3364992"/>
+            <a:off x="6446520" y="3840480"/>
             <a:ext cx="1828800" cy="502920"/>
           </a:xfrm>
           <a:prstGeom prst="rect">
@@ -5762,7 +5807,7 @@
           <a:p>
             <a:pPr algn="ctr"/>
             <a:r>
-              <a:rPr sz="800" b="0">
+              <a:rPr sz="800" b="0" dirty="0">
                 <a:solidFill>
                   <a:srgbClr val="605E5C"/>
                 </a:solidFill>
@@ -5854,7 +5899,7 @@
 </file>
 
 <file path=ppt/slides/slide4.xml><?xml version="1.0" encoding="utf-8"?>
-<p:sld xmlns:a="http://schemas.openxmlformats.org/drawingml/2006/main" xmlns:p="http://schemas.openxmlformats.org/presentationml/2006/main" xmlns:r="http://schemas.openxmlformats.org/officeDocument/2006/relationships">
+<p:sld xmlns:a="http://schemas.openxmlformats.org/drawingml/2006/main" xmlns:r="http://schemas.openxmlformats.org/officeDocument/2006/relationships" xmlns:p="http://schemas.openxmlformats.org/presentationml/2006/main">
   <p:cSld>
     <p:spTree>
       <p:nvGrpSpPr>
@@ -5862,7 +5907,14 @@
         <p:cNvGrpSpPr/>
         <p:nvPr/>
       </p:nvGrpSpPr>
-      <p:grpSpPr/>
+      <p:grpSpPr>
+        <a:xfrm>
+          <a:off x="0" y="0"/>
+          <a:ext cx="0" cy="0"/>
+          <a:chOff x="0" y="0"/>
+          <a:chExt cx="0" cy="0"/>
+        </a:xfrm>
+      </p:grpSpPr>
       <p:sp>
         <p:nvSpPr>
           <p:cNvPr id="2" name="Rectangle 1"/>
@@ -5903,6 +5955,7 @@
           <a:lstStyle/>
           <a:p>
             <a:pPr algn="ctr"/>
+            <a:endParaRPr/>
           </a:p>
         </p:txBody>
       </p:sp>
@@ -5946,6 +5999,7 @@
           <a:lstStyle/>
           <a:p>
             <a:pPr algn="ctr"/>
+            <a:endParaRPr/>
           </a:p>
         </p:txBody>
       </p:sp>
@@ -6059,6 +6113,7 @@
           <a:lstStyle/>
           <a:p>
             <a:pPr algn="ctr"/>
+            <a:endParaRPr/>
           </a:p>
         </p:txBody>
       </p:sp>
@@ -6139,6 +6194,7 @@
           <a:lstStyle/>
           <a:p>
             <a:pPr algn="ctr"/>
+            <a:endParaRPr/>
           </a:p>
         </p:txBody>
       </p:sp>
@@ -6182,6 +6238,7 @@
           <a:lstStyle/>
           <a:p>
             <a:pPr algn="ctr"/>
+            <a:endParaRPr/>
           </a:p>
         </p:txBody>
       </p:sp>
@@ -6397,6 +6454,7 @@
           <a:lstStyle/>
           <a:p>
             <a:pPr algn="ctr"/>
+            <a:endParaRPr/>
           </a:p>
         </p:txBody>
       </p:sp>
@@ -6480,6 +6538,7 @@
           <a:lstStyle/>
           <a:p>
             <a:pPr algn="ctr"/>
+            <a:endParaRPr/>
           </a:p>
         </p:txBody>
       </p:sp>
@@ -6523,6 +6582,7 @@
           <a:lstStyle/>
           <a:p>
             <a:pPr algn="ctr"/>
+            <a:endParaRPr/>
           </a:p>
         </p:txBody>
       </p:sp>
@@ -6738,6 +6798,7 @@
           <a:lstStyle/>
           <a:p>
             <a:pPr algn="ctr"/>
+            <a:endParaRPr/>
           </a:p>
         </p:txBody>
       </p:sp>
@@ -6821,6 +6882,7 @@
           <a:lstStyle/>
           <a:p>
             <a:pPr algn="ctr"/>
+            <a:endParaRPr/>
           </a:p>
         </p:txBody>
       </p:sp>
@@ -6864,6 +6926,7 @@
           <a:lstStyle/>
           <a:p>
             <a:pPr algn="ctr"/>
+            <a:endParaRPr/>
           </a:p>
         </p:txBody>
       </p:sp>
@@ -7079,6 +7142,7 @@
           <a:lstStyle/>
           <a:p>
             <a:pPr algn="ctr"/>
+            <a:endParaRPr/>
           </a:p>
         </p:txBody>
       </p:sp>
@@ -7131,7 +7195,7 @@
 </file>
 
 <file path=ppt/slides/slide5.xml><?xml version="1.0" encoding="utf-8"?>
-<p:sld xmlns:a="http://schemas.openxmlformats.org/drawingml/2006/main" xmlns:p="http://schemas.openxmlformats.org/presentationml/2006/main" xmlns:r="http://schemas.openxmlformats.org/officeDocument/2006/relationships">
+<p:sld xmlns:a="http://schemas.openxmlformats.org/drawingml/2006/main" xmlns:r="http://schemas.openxmlformats.org/officeDocument/2006/relationships" xmlns:p="http://schemas.openxmlformats.org/presentationml/2006/main">
   <p:cSld>
     <p:spTree>
       <p:nvGrpSpPr>
@@ -7139,7 +7203,14 @@
         <p:cNvGrpSpPr/>
         <p:nvPr/>
       </p:nvGrpSpPr>
-      <p:grpSpPr/>
+      <p:grpSpPr>
+        <a:xfrm>
+          <a:off x="0" y="0"/>
+          <a:ext cx="0" cy="0"/>
+          <a:chOff x="0" y="0"/>
+          <a:chExt cx="0" cy="0"/>
+        </a:xfrm>
+      </p:grpSpPr>
       <p:sp>
         <p:nvSpPr>
           <p:cNvPr id="2" name="Rectangle 1"/>
@@ -7180,6 +7251,7 @@
           <a:lstStyle/>
           <a:p>
             <a:pPr algn="ctr"/>
+            <a:endParaRPr/>
           </a:p>
         </p:txBody>
       </p:sp>
@@ -7223,6 +7295,7 @@
           <a:lstStyle/>
           <a:p>
             <a:pPr algn="ctr"/>
+            <a:endParaRPr/>
           </a:p>
         </p:txBody>
       </p:sp>
@@ -7336,6 +7409,7 @@
           <a:lstStyle/>
           <a:p>
             <a:pPr algn="ctr"/>
+            <a:endParaRPr/>
           </a:p>
         </p:txBody>
       </p:sp>
@@ -7827,6 +7901,7 @@
           <a:lstStyle/>
           <a:p>
             <a:pPr algn="ctr"/>
+            <a:endParaRPr/>
           </a:p>
         </p:txBody>
       </p:sp>
@@ -7939,6 +8014,7 @@
           <a:lstStyle/>
           <a:p>
             <a:pPr algn="ctr"/>
+            <a:endParaRPr/>
           </a:p>
         </p:txBody>
       </p:sp>
@@ -8084,6 +8160,7 @@
           <a:lstStyle/>
           <a:p>
             <a:pPr algn="ctr"/>
+            <a:endParaRPr/>
           </a:p>
         </p:txBody>
       </p:sp>
@@ -8198,7 +8275,7 @@
 </file>
 
 <file path=ppt/slides/slide6.xml><?xml version="1.0" encoding="utf-8"?>
-<p:sld xmlns:a="http://schemas.openxmlformats.org/drawingml/2006/main" xmlns:p="http://schemas.openxmlformats.org/presentationml/2006/main" xmlns:r="http://schemas.openxmlformats.org/officeDocument/2006/relationships">
+<p:sld xmlns:a="http://schemas.openxmlformats.org/drawingml/2006/main" xmlns:r="http://schemas.openxmlformats.org/officeDocument/2006/relationships" xmlns:p="http://schemas.openxmlformats.org/presentationml/2006/main">
   <p:cSld>
     <p:spTree>
       <p:nvGrpSpPr>
@@ -8206,7 +8283,14 @@
         <p:cNvGrpSpPr/>
         <p:nvPr/>
       </p:nvGrpSpPr>
-      <p:grpSpPr/>
+      <p:grpSpPr>
+        <a:xfrm>
+          <a:off x="0" y="0"/>
+          <a:ext cx="0" cy="0"/>
+          <a:chOff x="0" y="0"/>
+          <a:chExt cx="0" cy="0"/>
+        </a:xfrm>
+      </p:grpSpPr>
       <p:sp>
         <p:nvSpPr>
           <p:cNvPr id="2" name="Rectangle 1"/>
@@ -8247,6 +8331,7 @@
           <a:lstStyle/>
           <a:p>
             <a:pPr algn="ctr"/>
+            <a:endParaRPr/>
           </a:p>
         </p:txBody>
       </p:sp>
@@ -8290,6 +8375,7 @@
           <a:lstStyle/>
           <a:p>
             <a:pPr algn="ctr"/>
+            <a:endParaRPr/>
           </a:p>
         </p:txBody>
       </p:sp>
@@ -8403,6 +8489,7 @@
           <a:lstStyle/>
           <a:p>
             <a:pPr algn="ctr"/>
+            <a:endParaRPr/>
           </a:p>
         </p:txBody>
       </p:sp>
@@ -8483,6 +8570,7 @@
           <a:lstStyle/>
           <a:p>
             <a:pPr algn="ctr"/>
+            <a:endParaRPr/>
           </a:p>
         </p:txBody>
       </p:sp>
@@ -8526,6 +8614,7 @@
           <a:lstStyle/>
           <a:p>
             <a:pPr algn="ctr"/>
+            <a:endParaRPr/>
           </a:p>
         </p:txBody>
       </p:sp>
@@ -8640,15 +8729,12 @@
                 <a:spcPts val="200"/>
               </a:spcBef>
             </a:pPr>
-            <a:r>
-              <a:rPr sz="1000">
-                <a:solidFill>
-                  <a:srgbClr val="323030"/>
-                </a:solidFill>
-                <a:latin typeface="Segoe UI"/>
-              </a:rPr>
-              <a:t/>
-            </a:r>
+            <a:endParaRPr sz="1000">
+              <a:solidFill>
+                <a:srgbClr val="323030"/>
+              </a:solidFill>
+              <a:latin typeface="Segoe UI"/>
+            </a:endParaRPr>
           </a:p>
           <a:p>
             <a:pPr>
@@ -8710,6 +8796,7 @@
           <a:lstStyle/>
           <a:p>
             <a:pPr algn="ctr"/>
+            <a:endParaRPr/>
           </a:p>
         </p:txBody>
       </p:sp>
@@ -8753,6 +8840,7 @@
           <a:lstStyle/>
           <a:p>
             <a:pPr algn="ctr"/>
+            <a:endParaRPr/>
           </a:p>
         </p:txBody>
       </p:sp>
@@ -8867,15 +8955,12 @@
                 <a:spcPts val="200"/>
               </a:spcBef>
             </a:pPr>
-            <a:r>
-              <a:rPr sz="1000">
-                <a:solidFill>
-                  <a:srgbClr val="323030"/>
-                </a:solidFill>
-                <a:latin typeface="Segoe UI"/>
-              </a:rPr>
-              <a:t/>
-            </a:r>
+            <a:endParaRPr sz="1000">
+              <a:solidFill>
+                <a:srgbClr val="323030"/>
+              </a:solidFill>
+              <a:latin typeface="Segoe UI"/>
+            </a:endParaRPr>
           </a:p>
           <a:p>
             <a:pPr>
@@ -8937,6 +9022,7 @@
           <a:lstStyle/>
           <a:p>
             <a:pPr algn="ctr"/>
+            <a:endParaRPr/>
           </a:p>
         </p:txBody>
       </p:sp>
@@ -8980,6 +9066,7 @@
           <a:lstStyle/>
           <a:p>
             <a:pPr algn="ctr"/>
+            <a:endParaRPr/>
           </a:p>
         </p:txBody>
       </p:sp>
@@ -9062,15 +9149,12 @@
                 <a:spcPts val="200"/>
               </a:spcBef>
             </a:pPr>
-            <a:r>
-              <a:rPr sz="1000">
-                <a:solidFill>
-                  <a:srgbClr val="323030"/>
-                </a:solidFill>
-                <a:latin typeface="Segoe UI"/>
-              </a:rPr>
-              <a:t/>
-            </a:r>
+            <a:endParaRPr sz="1000">
+              <a:solidFill>
+                <a:srgbClr val="323030"/>
+              </a:solidFill>
+              <a:latin typeface="Segoe UI"/>
+            </a:endParaRPr>
           </a:p>
           <a:p>
             <a:pPr>
@@ -9094,15 +9178,12 @@
                 <a:spcPts val="200"/>
               </a:spcBef>
             </a:pPr>
-            <a:r>
-              <a:rPr sz="1000">
-                <a:solidFill>
-                  <a:srgbClr val="323030"/>
-                </a:solidFill>
-                <a:latin typeface="Segoe UI"/>
-              </a:rPr>
-              <a:t/>
-            </a:r>
+            <a:endParaRPr sz="1000">
+              <a:solidFill>
+                <a:srgbClr val="323030"/>
+              </a:solidFill>
+              <a:latin typeface="Segoe UI"/>
+            </a:endParaRPr>
           </a:p>
           <a:p>
             <a:pPr>
@@ -9212,6 +9293,7 @@
           <a:lstStyle/>
           <a:p>
             <a:pPr algn="ctr"/>
+            <a:endParaRPr/>
           </a:p>
         </p:txBody>
       </p:sp>
@@ -9255,6 +9337,7 @@
           <a:lstStyle/>
           <a:p>
             <a:pPr algn="ctr"/>
+            <a:endParaRPr/>
           </a:p>
         </p:txBody>
       </p:sp>
@@ -9336,15 +9419,12 @@
                 <a:spcPts val="200"/>
               </a:spcBef>
             </a:pPr>
-            <a:r>
-              <a:rPr sz="1000">
-                <a:solidFill>
-                  <a:srgbClr val="323030"/>
-                </a:solidFill>
-                <a:latin typeface="Segoe UI"/>
-              </a:rPr>
-              <a:t/>
-            </a:r>
+            <a:endParaRPr sz="1000">
+              <a:solidFill>
+                <a:srgbClr val="323030"/>
+              </a:solidFill>
+              <a:latin typeface="Segoe UI"/>
+            </a:endParaRPr>
           </a:p>
           <a:p>
             <a:pPr>
@@ -9400,15 +9480,12 @@
                 <a:spcPts val="200"/>
               </a:spcBef>
             </a:pPr>
-            <a:r>
-              <a:rPr sz="1000">
-                <a:solidFill>
-                  <a:srgbClr val="323030"/>
-                </a:solidFill>
-                <a:latin typeface="Segoe UI"/>
-              </a:rPr>
-              <a:t/>
-            </a:r>
+            <a:endParaRPr sz="1000">
+              <a:solidFill>
+                <a:srgbClr val="323030"/>
+              </a:solidFill>
+              <a:latin typeface="Segoe UI"/>
+            </a:endParaRPr>
           </a:p>
           <a:p>
             <a:pPr>
@@ -9470,6 +9547,7 @@
           <a:lstStyle/>
           <a:p>
             <a:pPr algn="ctr"/>
+            <a:endParaRPr/>
           </a:p>
         </p:txBody>
       </p:sp>
@@ -9517,7 +9595,7 @@
 </file>
 
 <file path=ppt/slides/slide7.xml><?xml version="1.0" encoding="utf-8"?>
-<p:sld xmlns:a="http://schemas.openxmlformats.org/drawingml/2006/main" xmlns:p="http://schemas.openxmlformats.org/presentationml/2006/main" xmlns:r="http://schemas.openxmlformats.org/officeDocument/2006/relationships">
+<p:sld xmlns:a="http://schemas.openxmlformats.org/drawingml/2006/main" xmlns:r="http://schemas.openxmlformats.org/officeDocument/2006/relationships" xmlns:p="http://schemas.openxmlformats.org/presentationml/2006/main">
   <p:cSld>
     <p:spTree>
       <p:nvGrpSpPr>
@@ -9525,7 +9603,14 @@
         <p:cNvGrpSpPr/>
         <p:nvPr/>
       </p:nvGrpSpPr>
-      <p:grpSpPr/>
+      <p:grpSpPr>
+        <a:xfrm>
+          <a:off x="0" y="0"/>
+          <a:ext cx="0" cy="0"/>
+          <a:chOff x="0" y="0"/>
+          <a:chExt cx="0" cy="0"/>
+        </a:xfrm>
+      </p:grpSpPr>
       <p:sp>
         <p:nvSpPr>
           <p:cNvPr id="2" name="Rectangle 1"/>
@@ -9566,6 +9651,7 @@
           <a:lstStyle/>
           <a:p>
             <a:pPr algn="ctr"/>
+            <a:endParaRPr/>
           </a:p>
         </p:txBody>
       </p:sp>
@@ -9609,6 +9695,7 @@
           <a:lstStyle/>
           <a:p>
             <a:pPr algn="ctr"/>
+            <a:endParaRPr/>
           </a:p>
         </p:txBody>
       </p:sp>
@@ -9722,6 +9809,7 @@
           <a:lstStyle/>
           <a:p>
             <a:pPr algn="ctr"/>
+            <a:endParaRPr/>
           </a:p>
         </p:txBody>
       </p:sp>
@@ -9802,6 +9890,7 @@
           <a:lstStyle/>
           <a:p>
             <a:pPr algn="ctr"/>
+            <a:endParaRPr/>
           </a:p>
         </p:txBody>
       </p:sp>
@@ -9845,6 +9934,7 @@
           <a:lstStyle/>
           <a:p>
             <a:pPr algn="ctr"/>
+            <a:endParaRPr/>
           </a:p>
         </p:txBody>
       </p:sp>
@@ -9974,15 +10064,12 @@
                 <a:spcPts val="400"/>
               </a:spcBef>
             </a:pPr>
-            <a:r>
-              <a:rPr sz="1100">
-                <a:solidFill>
-                  <a:srgbClr val="323030"/>
-                </a:solidFill>
-                <a:latin typeface="Segoe UI"/>
-              </a:rPr>
-              <a:t/>
-            </a:r>
+            <a:endParaRPr sz="1100">
+              <a:solidFill>
+                <a:srgbClr val="323030"/>
+              </a:solidFill>
+              <a:latin typeface="Segoe UI"/>
+            </a:endParaRPr>
           </a:p>
           <a:p>
             <a:pPr>
@@ -10060,6 +10147,7 @@
           <a:lstStyle/>
           <a:p>
             <a:pPr algn="ctr"/>
+            <a:endParaRPr/>
           </a:p>
         </p:txBody>
       </p:sp>
@@ -10103,6 +10191,7 @@
           <a:lstStyle/>
           <a:p>
             <a:pPr algn="ctr"/>
+            <a:endParaRPr/>
           </a:p>
         </p:txBody>
       </p:sp>
@@ -10216,15 +10305,12 @@
                 <a:spcPts val="400"/>
               </a:spcBef>
             </a:pPr>
-            <a:r>
-              <a:rPr sz="1100">
-                <a:solidFill>
-                  <a:srgbClr val="323030"/>
-                </a:solidFill>
-                <a:latin typeface="Segoe UI"/>
-              </a:rPr>
-              <a:t/>
-            </a:r>
+            <a:endParaRPr sz="1100">
+              <a:solidFill>
+                <a:srgbClr val="323030"/>
+              </a:solidFill>
+              <a:latin typeface="Segoe UI"/>
+            </a:endParaRPr>
           </a:p>
           <a:p>
             <a:pPr>
@@ -10264,15 +10350,12 @@
                 <a:spcPts val="400"/>
               </a:spcBef>
             </a:pPr>
-            <a:r>
-              <a:rPr sz="1100">
-                <a:solidFill>
-                  <a:srgbClr val="323030"/>
-                </a:solidFill>
-                <a:latin typeface="Segoe UI"/>
-              </a:rPr>
-              <a:t/>
-            </a:r>
+            <a:endParaRPr sz="1100">
+              <a:solidFill>
+                <a:srgbClr val="323030"/>
+              </a:solidFill>
+              <a:latin typeface="Segoe UI"/>
+            </a:endParaRPr>
           </a:p>
           <a:p>
             <a:pPr>
@@ -10350,6 +10433,7 @@
           <a:lstStyle/>
           <a:p>
             <a:pPr algn="ctr"/>
+            <a:endParaRPr/>
           </a:p>
         </p:txBody>
       </p:sp>
@@ -10393,6 +10477,7 @@
           <a:lstStyle/>
           <a:p>
             <a:pPr algn="ctr"/>
+            <a:endParaRPr/>
           </a:p>
         </p:txBody>
       </p:sp>
@@ -10554,15 +10639,12 @@
                 <a:spcPts val="400"/>
               </a:spcBef>
             </a:pPr>
-            <a:r>
-              <a:rPr sz="1100">
-                <a:solidFill>
-                  <a:srgbClr val="323030"/>
-                </a:solidFill>
-                <a:latin typeface="Segoe UI"/>
-              </a:rPr>
-              <a:t/>
-            </a:r>
+            <a:endParaRPr sz="1100">
+              <a:solidFill>
+                <a:srgbClr val="323030"/>
+              </a:solidFill>
+              <a:latin typeface="Segoe UI"/>
+            </a:endParaRPr>
           </a:p>
           <a:p>
             <a:pPr>
@@ -10591,7 +10673,7 @@
 </file>
 
 <file path=ppt/slides/slide8.xml><?xml version="1.0" encoding="utf-8"?>
-<p:sld xmlns:a="http://schemas.openxmlformats.org/drawingml/2006/main" xmlns:p="http://schemas.openxmlformats.org/presentationml/2006/main" xmlns:r="http://schemas.openxmlformats.org/officeDocument/2006/relationships">
+<p:sld xmlns:a="http://schemas.openxmlformats.org/drawingml/2006/main" xmlns:r="http://schemas.openxmlformats.org/officeDocument/2006/relationships" xmlns:p="http://schemas.openxmlformats.org/presentationml/2006/main">
   <p:cSld>
     <p:spTree>
       <p:nvGrpSpPr>
@@ -10599,7 +10681,14 @@
         <p:cNvGrpSpPr/>
         <p:nvPr/>
       </p:nvGrpSpPr>
-      <p:grpSpPr/>
+      <p:grpSpPr>
+        <a:xfrm>
+          <a:off x="0" y="0"/>
+          <a:ext cx="0" cy="0"/>
+          <a:chOff x="0" y="0"/>
+          <a:chExt cx="0" cy="0"/>
+        </a:xfrm>
+      </p:grpSpPr>
       <p:sp>
         <p:nvSpPr>
           <p:cNvPr id="2" name="Rectangle 1"/>
@@ -10640,6 +10729,7 @@
           <a:lstStyle/>
           <a:p>
             <a:pPr algn="ctr"/>
+            <a:endParaRPr/>
           </a:p>
         </p:txBody>
       </p:sp>
@@ -10683,6 +10773,7 @@
           <a:lstStyle/>
           <a:p>
             <a:pPr algn="ctr"/>
+            <a:endParaRPr/>
           </a:p>
         </p:txBody>
       </p:sp>
@@ -10729,7 +10820,7 @@
         </p:nvSpPr>
         <p:spPr>
           <a:xfrm>
-            <a:off x="365760" y="731520"/>
+            <a:off x="365760" y="896112"/>
             <a:ext cx="10972800" cy="365760"/>
           </a:xfrm>
           <a:prstGeom prst="rect">
@@ -10745,7 +10836,7 @@
           <a:p>
             <a:pPr algn="l"/>
             <a:r>
-              <a:rPr sz="1400" b="0">
+              <a:rPr sz="1400" b="0" dirty="0">
                 <a:solidFill>
                   <a:srgbClr val="DEECF9"/>
                 </a:solidFill>
@@ -10796,6 +10887,7 @@
           <a:lstStyle/>
           <a:p>
             <a:pPr algn="ctr"/>
+            <a:endParaRPr/>
           </a:p>
         </p:txBody>
       </p:sp>
@@ -10807,7 +10899,7 @@
         </p:nvSpPr>
         <p:spPr>
           <a:xfrm>
-            <a:off x="274320" y="6510528"/>
+            <a:off x="274320" y="6647688"/>
             <a:ext cx="10972800" cy="274320"/>
           </a:xfrm>
           <a:prstGeom prst="rect">
@@ -10876,6 +10968,7 @@
           <a:lstStyle/>
           <a:p>
             <a:pPr algn="ctr"/>
+            <a:endParaRPr/>
           </a:p>
         </p:txBody>
       </p:sp>
@@ -10919,6 +11012,7 @@
           <a:lstStyle/>
           <a:p>
             <a:pPr algn="ctr"/>
+            <a:endParaRPr/>
           </a:p>
         </p:txBody>
       </p:sp>
@@ -11034,6 +11128,7 @@
           <a:lstStyle/>
           <a:p>
             <a:pPr algn="ctr"/>
+            <a:endParaRPr/>
           </a:p>
         </p:txBody>
       </p:sp>
@@ -11077,6 +11172,7 @@
           <a:lstStyle/>
           <a:p>
             <a:pPr algn="ctr"/>
+            <a:endParaRPr/>
           </a:p>
         </p:txBody>
       </p:sp>
@@ -11192,6 +11288,7 @@
           <a:lstStyle/>
           <a:p>
             <a:pPr algn="ctr"/>
+            <a:endParaRPr/>
           </a:p>
         </p:txBody>
       </p:sp>
@@ -11235,6 +11332,7 @@
           <a:lstStyle/>
           <a:p>
             <a:pPr algn="ctr"/>
+            <a:endParaRPr/>
           </a:p>
         </p:txBody>
       </p:sp>
@@ -11383,6 +11481,7 @@
           <a:lstStyle/>
           <a:p>
             <a:pPr algn="ctr"/>
+            <a:endParaRPr/>
           </a:p>
         </p:txBody>
       </p:sp>
@@ -11461,6 +11560,7 @@
           <a:lstStyle/>
           <a:p>
             <a:pPr algn="ctr"/>
+            <a:endParaRPr/>
           </a:p>
         </p:txBody>
       </p:sp>
@@ -11539,6 +11639,7 @@
           <a:lstStyle/>
           <a:p>
             <a:pPr algn="ctr"/>
+            <a:endParaRPr/>
           </a:p>
         </p:txBody>
       </p:sp>
@@ -11617,6 +11718,7 @@
           <a:lstStyle/>
           <a:p>
             <a:pPr algn="ctr"/>
+            <a:endParaRPr/>
           </a:p>
         </p:txBody>
       </p:sp>
@@ -11695,6 +11797,7 @@
           <a:lstStyle/>
           <a:p>
             <a:pPr algn="ctr"/>
+            <a:endParaRPr/>
           </a:p>
         </p:txBody>
       </p:sp>
@@ -11773,6 +11876,7 @@
           <a:lstStyle/>
           <a:p>
             <a:pPr algn="ctr"/>
+            <a:endParaRPr/>
           </a:p>
         </p:txBody>
       </p:sp>
@@ -11851,6 +11955,7 @@
           <a:lstStyle/>
           <a:p>
             <a:pPr algn="ctr"/>
+            <a:endParaRPr/>
           </a:p>
         </p:txBody>
       </p:sp>
@@ -11929,6 +12034,7 @@
           <a:lstStyle/>
           <a:p>
             <a:pPr algn="ctr"/>
+            <a:endParaRPr/>
           </a:p>
         </p:txBody>
       </p:sp>
@@ -12007,6 +12113,7 @@
           <a:lstStyle/>
           <a:p>
             <a:pPr algn="ctr"/>
+            <a:endParaRPr/>
           </a:p>
         </p:txBody>
       </p:sp>
@@ -12085,6 +12192,7 @@
           <a:lstStyle/>
           <a:p>
             <a:pPr algn="ctr"/>
+            <a:endParaRPr/>
           </a:p>
         </p:txBody>
       </p:sp>
@@ -12163,6 +12271,7 @@
           <a:lstStyle/>
           <a:p>
             <a:pPr algn="ctr"/>
+            <a:endParaRPr/>
           </a:p>
         </p:txBody>
       </p:sp>
@@ -12241,6 +12350,7 @@
           <a:lstStyle/>
           <a:p>
             <a:pPr algn="ctr"/>
+            <a:endParaRPr/>
           </a:p>
         </p:txBody>
       </p:sp>
@@ -12319,6 +12429,7 @@
           <a:lstStyle/>
           <a:p>
             <a:pPr algn="ctr"/>
+            <a:endParaRPr/>
           </a:p>
         </p:txBody>
       </p:sp>
@@ -12397,6 +12508,7 @@
           <a:lstStyle/>
           <a:p>
             <a:pPr algn="ctr"/>
+            <a:endParaRPr/>
           </a:p>
         </p:txBody>
       </p:sp>
@@ -12475,6 +12587,7 @@
           <a:lstStyle/>
           <a:p>
             <a:pPr algn="ctr"/>
+            <a:endParaRPr/>
           </a:p>
         </p:txBody>
       </p:sp>
@@ -12553,6 +12666,7 @@
           <a:lstStyle/>
           <a:p>
             <a:pPr algn="ctr"/>
+            <a:endParaRPr/>
           </a:p>
         </p:txBody>
       </p:sp>
@@ -12631,6 +12745,7 @@
           <a:lstStyle/>
           <a:p>
             <a:pPr algn="ctr"/>
+            <a:endParaRPr/>
           </a:p>
         </p:txBody>
       </p:sp>
@@ -12709,6 +12824,7 @@
           <a:lstStyle/>
           <a:p>
             <a:pPr algn="ctr"/>
+            <a:endParaRPr/>
           </a:p>
         </p:txBody>
       </p:sp>
@@ -12787,6 +12903,7 @@
           <a:lstStyle/>
           <a:p>
             <a:pPr algn="ctr"/>
+            <a:endParaRPr/>
           </a:p>
         </p:txBody>
       </p:sp>
@@ -12865,6 +12982,7 @@
           <a:lstStyle/>
           <a:p>
             <a:pPr algn="ctr"/>
+            <a:endParaRPr/>
           </a:p>
         </p:txBody>
       </p:sp>
@@ -12912,7 +13030,7 @@
 </file>
 
 <file path=ppt/slides/slide9.xml><?xml version="1.0" encoding="utf-8"?>
-<p:sld xmlns:a="http://schemas.openxmlformats.org/drawingml/2006/main" xmlns:p="http://schemas.openxmlformats.org/presentationml/2006/main" xmlns:r="http://schemas.openxmlformats.org/officeDocument/2006/relationships">
+<p:sld xmlns:a="http://schemas.openxmlformats.org/drawingml/2006/main" xmlns:r="http://schemas.openxmlformats.org/officeDocument/2006/relationships" xmlns:p="http://schemas.openxmlformats.org/presentationml/2006/main">
   <p:cSld>
     <p:spTree>
       <p:nvGrpSpPr>
@@ -12920,7 +13038,14 @@
         <p:cNvGrpSpPr/>
         <p:nvPr/>
       </p:nvGrpSpPr>
-      <p:grpSpPr/>
+      <p:grpSpPr>
+        <a:xfrm>
+          <a:off x="0" y="0"/>
+          <a:ext cx="0" cy="0"/>
+          <a:chOff x="0" y="0"/>
+          <a:chExt cx="0" cy="0"/>
+        </a:xfrm>
+      </p:grpSpPr>
       <p:sp>
         <p:nvSpPr>
           <p:cNvPr id="2" name="Rectangle 1"/>
@@ -12961,6 +13086,7 @@
           <a:lstStyle/>
           <a:p>
             <a:pPr algn="ctr"/>
+            <a:endParaRPr/>
           </a:p>
         </p:txBody>
       </p:sp>
@@ -13004,6 +13130,7 @@
           <a:lstStyle/>
           <a:p>
             <a:pPr algn="ctr"/>
+            <a:endParaRPr/>
           </a:p>
         </p:txBody>
       </p:sp>
@@ -13117,6 +13244,7 @@
           <a:lstStyle/>
           <a:p>
             <a:pPr algn="ctr"/>
+            <a:endParaRPr/>
           </a:p>
         </p:txBody>
       </p:sp>
@@ -13197,6 +13325,7 @@
           <a:lstStyle/>
           <a:p>
             <a:pPr algn="ctr"/>
+            <a:endParaRPr/>
           </a:p>
         </p:txBody>
       </p:sp>
@@ -13240,6 +13369,7 @@
           <a:lstStyle/>
           <a:p>
             <a:pPr algn="ctr"/>
+            <a:endParaRPr/>
           </a:p>
         </p:txBody>
       </p:sp>
@@ -13320,6 +13450,7 @@
           <a:lstStyle/>
           <a:p>
             <a:pPr algn="ctr"/>
+            <a:endParaRPr/>
           </a:p>
         </p:txBody>
       </p:sp>
@@ -13509,6 +13640,7 @@
           <a:lstStyle/>
           <a:p>
             <a:pPr algn="ctr"/>
+            <a:endParaRPr/>
           </a:p>
         </p:txBody>
       </p:sp>
@@ -13552,6 +13684,7 @@
           <a:lstStyle/>
           <a:p>
             <a:pPr algn="ctr"/>
+            <a:endParaRPr/>
           </a:p>
         </p:txBody>
       </p:sp>
@@ -13632,6 +13765,7 @@
           <a:lstStyle/>
           <a:p>
             <a:pPr algn="ctr"/>
+            <a:endParaRPr/>
           </a:p>
         </p:txBody>
       </p:sp>
@@ -13821,6 +13955,7 @@
           <a:lstStyle/>
           <a:p>
             <a:pPr algn="ctr"/>
+            <a:endParaRPr/>
           </a:p>
         </p:txBody>
       </p:sp>
@@ -13864,6 +13999,7 @@
           <a:lstStyle/>
           <a:p>
             <a:pPr algn="ctr"/>
+            <a:endParaRPr/>
           </a:p>
         </p:txBody>
       </p:sp>
@@ -13944,6 +14080,7 @@
           <a:lstStyle/>
           <a:p>
             <a:pPr algn="ctr"/>
+            <a:endParaRPr/>
           </a:p>
         </p:txBody>
       </p:sp>
@@ -14135,6 +14272,7 @@
           <a:lstStyle/>
           <a:p>
             <a:pPr algn="ctr"/>
+            <a:endParaRPr/>
           </a:p>
         </p:txBody>
       </p:sp>
@@ -14499,4 +14637,10 @@
   </a:objectDefaults>
   <a:extraClrSchemeLst/>
 </a:theme>
+</file>
+
+<file path=docMetadata/LabelInfo.xml><?xml version="1.0" encoding="utf-8"?>
+<clbl:labelList xmlns:clbl="http://schemas.microsoft.com/office/2020/mipLabelMetadata">
+  <clbl:label id="{f42aa342-8706-4288-bd11-ebb85995028c}" enabled="1" method="Standard" siteId="{72f988bf-86f1-41af-91ab-2d7cd011db47}" contentBits="0" removed="0"/>
+</clbl:labelList>
 </file>
</xml_diff>